<commit_message>
docs: v2.0 whitepaper & tokenomics (EN) for TRV fair launch on Solana/pump.fun; README and deck updated; remove unverifiable team bios
</commit_message>
<xml_diff>
--- a/Traverse_PitchDeck.pptx
+++ b/Traverse_PitchDeck.pptx
@@ -141,7 +141,7 @@
               <c:strCache>
                 <c:ptCount val="1"/>
                 <c:pt idx="0">
-                  <c:v>VTX Supply</c:v>
+                  <c:v>TRV Supply</c:v>
                 </c:pt>
               </c:strCache>
             </c:strRef>
@@ -431,58 +431,29 @@
           </c:dLbls>
           <c:cat>
             <c:strRef>
-              <c:f>Sheet1!$A$2:$A$8</c:f>
+              <c:f>Sheet1!$A$2:$A$3</c:f>
               <c:strCache>
-                <c:ptCount val="7"/>
+                <c:ptCount val="2"/>
                 <c:pt idx="0">
-                  <c:v>Comunidade 35%</c:v>
+                  <c:v>Bonding curve ~79.3%</c:v>
                 </c:pt>
                 <c:pt idx="1">
-                  <c:v>Equipe 18%</c:v>
-                </c:pt>
-                <c:pt idx="2">
-                  <c:v>Tesouro 20%</c:v>
-                </c:pt>
-                <c:pt idx="3">
-                  <c:v>Seed 8%</c:v>
-                </c:pt>
-                <c:pt idx="4">
-                  <c:v>Serie A 7%</c:v>
-                </c:pt>
-                <c:pt idx="5">
-                  <c:v>Liquidez 7%</c:v>
-                </c:pt>
-                <c:pt idx="6">
-                  <c:v>Airdrop 5%</c:v>
+                  <c:v>Liquidity reserve ~20.7%</c:v>
                 </c:pt>
               </c:strCache>
             </c:strRef>
           </c:cat>
           <c:val>
             <c:numRef>
-              <c:f>Sheet1!$B$2:$B$8</c:f>
+              <c:f>Sheet1!$B$2:$B$3</c:f>
               <c:numCache>
-                <c:ptCount val="7"/>
+                <c:formatCode>General</c:formatCode>
+                <c:ptCount val="2"/>
                 <c:pt idx="0">
-                  <c:v>35</c:v>
+                  <c:v>79.3</c:v>
                 </c:pt>
                 <c:pt idx="1">
-                  <c:v>18</c:v>
-                </c:pt>
-                <c:pt idx="2">
-                  <c:v>20</c:v>
-                </c:pt>
-                <c:pt idx="3">
-                  <c:v>8</c:v>
-                </c:pt>
-                <c:pt idx="4">
-                  <c:v>7</c:v>
-                </c:pt>
-                <c:pt idx="5">
-                  <c:v>7</c:v>
-                </c:pt>
-                <c:pt idx="6">
-                  <c:v>5</c:v>
+                  <c:v>20.7</c:v>
                 </c:pt>
               </c:numCache>
             </c:numRef>
@@ -555,7 +526,7 @@
               <c:strCache>
                 <c:ptCount val="1"/>
                 <c:pt idx="0">
-                  <c:v>Fee Mensal (USD)</c:v>
+                  <c:v>Monthly fees (USD)</c:v>
                 </c:pt>
               </c:strCache>
             </c:strRef>
@@ -625,23 +596,21 @@
             </c:spPr>
           </c:dPt>
           <c:cat>
-            <c:multiLvlStrRef>
+            <c:strRef>
               <c:f>Sheet1!$A$2:$A$4</c:f>
-              <c:multiLvlStrCache>
+              <c:strCache>
                 <c:ptCount val="3"/>
-                <c:lvl>
-                  <c:pt idx="0">
-                    <c:v>Conservador</c:v>
-                  </c:pt>
-                  <c:pt idx="1">
-                    <c:v>Base</c:v>
-                  </c:pt>
-                  <c:pt idx="2">
-                    <c:v>Otimista</c:v>
-                  </c:pt>
-                </c:lvl>
-              </c:multiLvlStrCache>
-            </c:multiLvlStrRef>
+                <c:pt idx="0">
+                  <c:v>Conservative</c:v>
+                </c:pt>
+                <c:pt idx="1">
+                  <c:v>Base</c:v>
+                </c:pt>
+                <c:pt idx="2">
+                  <c:v>Optimistic</c:v>
+                </c:pt>
+              </c:strCache>
+            </c:strRef>
           </c:cat>
           <c:val>
             <c:numRef>
@@ -3060,7 +3029,7 @@
                 <a:ea typeface="Calibri" pitchFamily="34" charset="-122"/>
                 <a:cs typeface="Calibri" pitchFamily="34" charset="-120"/>
               </a:rPr>
-              <a:t>Conectando liquidez em um único fluxo</a:t>
+              <a:t>Cross-chain liquidity, routed by intent</a:t>
             </a:r>
             <a:endParaRPr lang="en-US" sz="2200" dirty="0"/>
           </a:p>
@@ -3099,7 +3068,7 @@
                 <a:ea typeface="Calibri" pitchFamily="34" charset="-122"/>
                 <a:cs typeface="Calibri" pitchFamily="34" charset="-120"/>
               </a:rPr>
-              <a:t>TRV Protocol  —  Investor Presentation  —  Junho 2026</a:t>
+              <a:t>TRV Protocol  —  Investor Presentation  —  October 2026  —  $TRV live on Solana</a:t>
             </a:r>
             <a:endParaRPr lang="en-US" sz="1400" dirty="0"/>
           </a:p>
@@ -3170,7 +3139,7 @@
                 <a:ea typeface="Georgia" pitchFamily="34" charset="-122"/>
                 <a:cs typeface="Georgia" pitchFamily="34" charset="-120"/>
               </a:rPr>
-              <a:t>Modelo Econômico Sustentável</a:t>
+              <a:t>Fee Model (Illustrative)</a:t>
             </a:r>
             <a:endParaRPr lang="en-US" sz="3000" dirty="0"/>
           </a:p>
@@ -3239,7 +3208,7 @@
                           <a:ea typeface="Calibri" pitchFamily="34" charset="-122"/>
                           <a:cs typeface="Calibri" pitchFamily="34" charset="-120"/>
                         </a:rPr>
-                        <a:t>Cenário</a:t>
+                        <a:t>Scenario</a:t>
                       </a:r>
                       <a:endParaRPr lang="en-US" sz="1200" dirty="0">
                         <a:latin typeface="Calibri" charset="0"/>
@@ -3307,7 +3276,7 @@
                           <a:ea typeface="Calibri" pitchFamily="34" charset="-122"/>
                           <a:cs typeface="Calibri" pitchFamily="34" charset="-120"/>
                         </a:rPr>
-                        <a:t>Volume/mês</a:t>
+                        <a:t>Volume/mo</a:t>
                       </a:r>
                       <a:endParaRPr lang="en-US" sz="1200" dirty="0">
                         <a:latin typeface="Calibri" charset="0"/>
@@ -3443,7 +3412,7 @@
                           <a:ea typeface="Calibri" pitchFamily="34" charset="-122"/>
                           <a:cs typeface="Calibri" pitchFamily="34" charset="-120"/>
                         </a:rPr>
-                        <a:t>Para Stakers</a:t>
+                        <a:t>Treasury (20%)</a:t>
                       </a:r>
                       <a:endParaRPr lang="en-US" sz="1200" dirty="0">
                         <a:latin typeface="Calibri" charset="0"/>
@@ -3511,7 +3480,7 @@
                           <a:ea typeface="Calibri" pitchFamily="34" charset="-122"/>
                           <a:cs typeface="Calibri" pitchFamily="34" charset="-120"/>
                         </a:rPr>
-                        <a:t>APY Est.</a:t>
+                        <a:t>Stakers (70%)*</a:t>
                       </a:r>
                       <a:endParaRPr lang="en-US" sz="1200" dirty="0">
                         <a:latin typeface="Calibri" charset="0"/>
@@ -3581,7 +3550,7 @@
                           <a:ea typeface="Calibri" pitchFamily="34" charset="-122"/>
                           <a:cs typeface="Calibri" pitchFamily="34" charset="-120"/>
                         </a:rPr>
-                        <a:t>Conservador</a:t>
+                        <a:t>Conservative</a:t>
                       </a:r>
                       <a:endParaRPr lang="en-US" sz="1200" dirty="0">
                         <a:latin typeface="Calibri" charset="0"/>
@@ -3785,7 +3754,7 @@
                           <a:ea typeface="Calibri" pitchFamily="34" charset="-122"/>
                           <a:cs typeface="Calibri" pitchFamily="34" charset="-120"/>
                         </a:rPr>
-                        <a:t>$17.5K</a:t>
+                        <a:t>$5K</a:t>
                       </a:r>
                       <a:endParaRPr lang="en-US" sz="1200" dirty="0">
                         <a:latin typeface="Calibri" charset="0"/>
@@ -3853,7 +3822,7 @@
                           <a:ea typeface="Calibri" pitchFamily="34" charset="-122"/>
                           <a:cs typeface="Calibri" pitchFamily="34" charset="-120"/>
                         </a:rPr>
-                        <a:t>~3%</a:t>
+                        <a:t>$17.5K</a:t>
                       </a:r>
                       <a:endParaRPr lang="en-US" sz="1200" dirty="0">
                         <a:latin typeface="Calibri" charset="0"/>
@@ -4127,7 +4096,7 @@
                           <a:ea typeface="Calibri" pitchFamily="34" charset="-122"/>
                           <a:cs typeface="Calibri" pitchFamily="34" charset="-120"/>
                         </a:rPr>
-                        <a:t>$175K</a:t>
+                        <a:t>$50K</a:t>
                       </a:r>
                       <a:endParaRPr lang="en-US" sz="1200" dirty="0">
                         <a:latin typeface="Calibri" charset="0"/>
@@ -4195,7 +4164,7 @@
                           <a:ea typeface="Calibri" pitchFamily="34" charset="-122"/>
                           <a:cs typeface="Calibri" pitchFamily="34" charset="-120"/>
                         </a:rPr>
-                        <a:t>~20%</a:t>
+                        <a:t>$175K</a:t>
                       </a:r>
                       <a:endParaRPr lang="en-US" sz="1200" dirty="0">
                         <a:latin typeface="Calibri" charset="0"/>
@@ -4265,7 +4234,7 @@
                           <a:ea typeface="Calibri" pitchFamily="34" charset="-122"/>
                           <a:cs typeface="Calibri" pitchFamily="34" charset="-120"/>
                         </a:rPr>
-                        <a:t>Otimista</a:t>
+                        <a:t>Optimistic</a:t>
                       </a:r>
                       <a:endParaRPr lang="en-US" sz="1200" dirty="0">
                         <a:latin typeface="Calibri" charset="0"/>
@@ -4469,7 +4438,7 @@
                           <a:ea typeface="Calibri" pitchFamily="34" charset="-122"/>
                           <a:cs typeface="Calibri" pitchFamily="34" charset="-120"/>
                         </a:rPr>
-                        <a:t>$700K</a:t>
+                        <a:t>$200K</a:t>
                       </a:r>
                       <a:endParaRPr lang="en-US" sz="1200" dirty="0">
                         <a:latin typeface="Calibri" charset="0"/>
@@ -4537,7 +4506,7 @@
                           <a:ea typeface="Calibri" pitchFamily="34" charset="-122"/>
                           <a:cs typeface="Calibri" pitchFamily="34" charset="-120"/>
                         </a:rPr>
-                        <a:t>~65%</a:t>
+                        <a:t>$700K</a:t>
                       </a:r>
                       <a:endParaRPr lang="en-US" sz="1200" dirty="0">
                         <a:latin typeface="Calibri" charset="0"/>
@@ -4626,7 +4595,7 @@
                 <a:ea typeface="Calibri" pitchFamily="34" charset="-122"/>
                 <a:cs typeface="Calibri" pitchFamily="34" charset="-120"/>
               </a:rPr>
-              <a:t>Projeções ilustrativas. Não constituem promessa de retorno.</a:t>
+              <a:t>Illustrative only. Fee distribution is a proposal, subject to legal review and governance. Not a promise of returns.</a:t>
             </a:r>
             <a:endParaRPr lang="en-US" sz="1000" dirty="0"/>
           </a:p>
@@ -4830,7 +4799,7 @@
                 <a:ea typeface="Georgia" pitchFamily="34" charset="-122"/>
                 <a:cs typeface="Georgia" pitchFamily="34" charset="-120"/>
               </a:rPr>
-              <a:t>Q3 2026</a:t>
+              <a:t>Q4 2026</a:t>
             </a:r>
             <a:endParaRPr lang="en-US" sz="1300" dirty="0"/>
           </a:p>
@@ -4869,7 +4838,7 @@
                 <a:ea typeface="Calibri" pitchFamily="34" charset="-122"/>
                 <a:cs typeface="Calibri" pitchFamily="34" charset="-120"/>
               </a:rPr>
-              <a:t>Testnet pública</a:t>
+              <a:t>TRV fair launch ✓</a:t>
             </a:r>
             <a:endParaRPr lang="en-US" sz="1200" dirty="0"/>
           </a:p>
@@ -4886,7 +4855,7 @@
                 <a:ea typeface="Calibri" pitchFamily="34" charset="-122"/>
                 <a:cs typeface="Calibri" pitchFamily="34" charset="-120"/>
               </a:rPr>
-              <a:t>Bug bounty</a:t>
+              <a:t>Base Sepolia testnet</a:t>
             </a:r>
             <a:endParaRPr lang="en-US" sz="1200" dirty="0"/>
           </a:p>
@@ -4903,7 +4872,7 @@
                 <a:ea typeface="Calibri" pitchFamily="34" charset="-122"/>
                 <a:cs typeface="Calibri" pitchFamily="34" charset="-120"/>
               </a:rPr>
-              <a:t>Auditorias</a:t>
+              <a:t>Solver reference bot</a:t>
             </a:r>
             <a:endParaRPr lang="en-US" sz="1200" dirty="0"/>
           </a:p>
@@ -5007,7 +4976,7 @@
                 <a:ea typeface="Georgia" pitchFamily="34" charset="-122"/>
                 <a:cs typeface="Georgia" pitchFamily="34" charset="-120"/>
               </a:rPr>
-              <a:t>Q4 2026</a:t>
+              <a:t>Q1 2027</a:t>
             </a:r>
             <a:endParaRPr lang="en-US" sz="1300" dirty="0"/>
           </a:p>
@@ -5046,7 +5015,7 @@
                 <a:ea typeface="Calibri" pitchFamily="34" charset="-122"/>
                 <a:cs typeface="Calibri" pitchFamily="34" charset="-120"/>
               </a:rPr>
-              <a:t>Mainnet Base+Arbitrum</a:t>
+              <a:t>Bridge design</a:t>
             </a:r>
             <a:endParaRPr lang="en-US" sz="1200" dirty="0"/>
           </a:p>
@@ -5063,7 +5032,7 @@
                 <a:ea typeface="Calibri" pitchFamily="34" charset="-122"/>
                 <a:cs typeface="Calibri" pitchFamily="34" charset="-120"/>
               </a:rPr>
-              <a:t>DEX launch</a:t>
+              <a:t>Testnet + test TRV</a:t>
             </a:r>
             <a:endParaRPr lang="en-US" sz="1200" dirty="0"/>
           </a:p>
@@ -5080,7 +5049,7 @@
                 <a:ea typeface="Calibri" pitchFamily="34" charset="-122"/>
                 <a:cs typeface="Calibri" pitchFamily="34" charset="-120"/>
               </a:rPr>
-              <a:t>Airdrop</a:t>
+              <a:t>Audit scoping</a:t>
             </a:r>
             <a:endParaRPr lang="en-US" sz="1200" dirty="0"/>
           </a:p>
@@ -5184,7 +5153,7 @@
                 <a:ea typeface="Georgia" pitchFamily="34" charset="-122"/>
                 <a:cs typeface="Georgia" pitchFamily="34" charset="-120"/>
               </a:rPr>
-              <a:t>Q1–Q2 2027</a:t>
+              <a:t>Q2 2027</a:t>
             </a:r>
             <a:endParaRPr lang="en-US" sz="1300" dirty="0"/>
           </a:p>
@@ -5223,7 +5192,7 @@
                 <a:ea typeface="Calibri" pitchFamily="34" charset="-122"/>
                 <a:cs typeface="Calibri" pitchFamily="34" charset="-120"/>
               </a:rPr>
-              <a:t>Solana + BSC</a:t>
+              <a:t>Independent audit</a:t>
             </a:r>
             <a:endParaRPr lang="en-US" sz="1200" dirty="0"/>
           </a:p>
@@ -5240,7 +5209,7 @@
                 <a:ea typeface="Calibri" pitchFamily="34" charset="-122"/>
                 <a:cs typeface="Calibri" pitchFamily="34" charset="-120"/>
               </a:rPr>
-              <a:t>Volume $100M+</a:t>
+              <a:t>Bug bounty</a:t>
             </a:r>
             <a:endParaRPr lang="en-US" sz="1200" dirty="0"/>
           </a:p>
@@ -5257,7 +5226,7 @@
                 <a:ea typeface="Calibri" pitchFamily="34" charset="-122"/>
                 <a:cs typeface="Calibri" pitchFamily="34" charset="-120"/>
               </a:rPr>
-              <a:t>Solver SDK</a:t>
+              <a:t>TRV bridged to Base</a:t>
             </a:r>
             <a:endParaRPr lang="en-US" sz="1200" dirty="0"/>
           </a:p>
@@ -5361,7 +5330,7 @@
                 <a:ea typeface="Georgia" pitchFamily="34" charset="-122"/>
                 <a:cs typeface="Georgia" pitchFamily="34" charset="-120"/>
               </a:rPr>
-              <a:t>Q3–Q4 2027</a:t>
+              <a:t>H2 2027</a:t>
             </a:r>
             <a:endParaRPr lang="en-US" sz="1300" dirty="0"/>
           </a:p>
@@ -5400,7 +5369,7 @@
                 <a:ea typeface="Calibri" pitchFamily="34" charset="-122"/>
                 <a:cs typeface="Calibri" pitchFamily="34" charset="-120"/>
               </a:rPr>
-              <a:t>Listagens CEX</a:t>
+              <a:t>Mainnet beta (Base)</a:t>
             </a:r>
             <a:endParaRPr lang="en-US" sz="1200" dirty="0"/>
           </a:p>
@@ -5417,7 +5386,7 @@
                 <a:ea typeface="Calibri" pitchFamily="34" charset="-122"/>
                 <a:cs typeface="Calibri" pitchFamily="34" charset="-120"/>
               </a:rPr>
-              <a:t>V2</a:t>
+              <a:t>Staking + governance</a:t>
             </a:r>
             <a:endParaRPr lang="en-US" sz="1200" dirty="0"/>
           </a:p>
@@ -5434,7 +5403,7 @@
                 <a:ea typeface="Calibri" pitchFamily="34" charset="-122"/>
                 <a:cs typeface="Calibri" pitchFamily="34" charset="-120"/>
               </a:rPr>
-              <a:t>Expansão global</a:t>
+              <a:t>Solver SDK</a:t>
             </a:r>
             <a:endParaRPr lang="en-US" sz="1200" dirty="0"/>
           </a:p>
@@ -5505,7 +5474,7 @@
                 <a:ea typeface="Georgia" pitchFamily="34" charset="-122"/>
                 <a:cs typeface="Georgia" pitchFamily="34" charset="-120"/>
               </a:rPr>
-              <a:t>Segurança Não É Opcional</a:t>
+              <a:t>Security Is Not Optional</a:t>
             </a:r>
             <a:endParaRPr lang="en-US" sz="3200" dirty="0"/>
           </a:p>
@@ -5641,7 +5610,7 @@
                 <a:ea typeface="Calibri" pitchFamily="34" charset="-122"/>
                 <a:cs typeface="Calibri" pitchFamily="34" charset="-120"/>
               </a:rPr>
-              <a:t>Auditoria independente por firma tier-1 antes da mainnet</a:t>
+              <a:t>Independent audit before any mainnet deployment (planned)</a:t>
             </a:r>
             <a:endParaRPr lang="en-US" sz="1300" dirty="0"/>
           </a:p>
@@ -5777,7 +5746,7 @@
                 <a:ea typeface="Calibri" pitchFamily="34" charset="-122"/>
                 <a:cs typeface="Calibri" pitchFamily="34" charset="-120"/>
               </a:rPr>
-              <a:t>Multisig Safe em todos os contratos críticos (4/7)</a:t>
+              <a:t>Safe multisig on critical contracts (planned)</a:t>
             </a:r>
             <a:endParaRPr lang="en-US" sz="1300" dirty="0"/>
           </a:p>
@@ -5913,7 +5882,7 @@
                 <a:ea typeface="Calibri" pitchFamily="34" charset="-122"/>
                 <a:cs typeface="Calibri" pitchFamily="34" charset="-120"/>
               </a:rPr>
-              <a:t>Timelock 48h em todas as mudanças de protocolo</a:t>
+              <a:t>48h timelock on all protocol changes</a:t>
             </a:r>
             <a:endParaRPr lang="en-US" sz="1300" dirty="0"/>
           </a:p>
@@ -6049,7 +6018,7 @@
                 <a:ea typeface="Calibri" pitchFamily="34" charset="-122"/>
                 <a:cs typeface="Calibri" pitchFamily="34" charset="-120"/>
               </a:rPr>
-              <a:t>Bug bounty $500K+ no Immunefi pós-launch</a:t>
+              <a:t>Immunefi bug bounty before mainnet (size TBD)</a:t>
             </a:r>
             <a:endParaRPr lang="en-US" sz="1300" dirty="0"/>
           </a:p>
@@ -6185,7 +6154,7 @@
                 <a:ea typeface="Calibri" pitchFamily="34" charset="-122"/>
                 <a:cs typeface="Calibri" pitchFamily="34" charset="-120"/>
               </a:rPr>
-              <a:t>Contratos verificados e open-source (Basescan/Arbiscan)</a:t>
+              <a:t>Open-source contracts, verified on Basescan at deployment</a:t>
             </a:r>
             <a:endParaRPr lang="en-US" sz="1300" dirty="0"/>
           </a:p>
@@ -6256,7 +6225,7 @@
                 <a:ea typeface="Georgia" pitchFamily="34" charset="-122"/>
                 <a:cs typeface="Georgia" pitchFamily="34" charset="-120"/>
               </a:rPr>
-              <a:t>Equipe</a:t>
+              <a:t>Team</a:t>
             </a:r>
             <a:endParaRPr lang="en-US" sz="3600" dirty="0"/>
           </a:p>
@@ -6360,7 +6329,7 @@
                 <a:ea typeface="Georgia" pitchFamily="34" charset="-122"/>
                 <a:cs typeface="Georgia" pitchFamily="34" charset="-120"/>
               </a:rPr>
-              <a:t>A</a:t>
+              <a:t>F</a:t>
             </a:r>
             <a:endParaRPr lang="en-US" sz="2200" dirty="0"/>
           </a:p>
@@ -6399,7 +6368,7 @@
                 <a:ea typeface="Georgia" pitchFamily="34" charset="-122"/>
                 <a:cs typeface="Georgia" pitchFamily="34" charset="-120"/>
               </a:rPr>
-              <a:t>Alex Martins</a:t>
+              <a:t>Founder</a:t>
             </a:r>
             <a:endParaRPr lang="en-US" sz="1300" dirty="0"/>
           </a:p>
@@ -6438,7 +6407,7 @@
                 <a:ea typeface="Calibri" pitchFamily="34" charset="-122"/>
                 <a:cs typeface="Calibri" pitchFamily="34" charset="-120"/>
               </a:rPr>
-              <a:t>CEO &amp; Co-Founder</a:t>
+              <a:t>Protocol &amp; Product</a:t>
             </a:r>
             <a:endParaRPr lang="en-US" sz="1100" dirty="0"/>
           </a:p>
@@ -6477,7 +6446,7 @@
                 <a:ea typeface="Calibri" pitchFamily="34" charset="-122"/>
                 <a:cs typeface="Calibri" pitchFamily="34" charset="-120"/>
               </a:rPr>
-              <a:t>Ex-Uniswap Labs</a:t>
+              <a:t>Name &amp; background published</a:t>
             </a:r>
             <a:endParaRPr lang="en-US" sz="1100" dirty="0"/>
           </a:p>
@@ -6494,7 +6463,7 @@
                 <a:ea typeface="Calibri" pitchFamily="34" charset="-122"/>
                 <a:cs typeface="Calibri" pitchFamily="34" charset="-120"/>
               </a:rPr>
-              <a:t>8 anos DeFi</a:t>
+              <a:t>with consent</a:t>
             </a:r>
             <a:endParaRPr lang="en-US" sz="1100" dirty="0"/>
           </a:p>
@@ -6637,7 +6606,7 @@
                 <a:ea typeface="Georgia" pitchFamily="34" charset="-122"/>
                 <a:cs typeface="Georgia" pitchFamily="34" charset="-120"/>
               </a:rPr>
-              <a:t>Sara Chen</a:t>
+              <a:t>Open role</a:t>
             </a:r>
             <a:endParaRPr lang="en-US" sz="1300" dirty="0"/>
           </a:p>
@@ -6676,7 +6645,7 @@
                 <a:ea typeface="Calibri" pitchFamily="34" charset="-122"/>
                 <a:cs typeface="Calibri" pitchFamily="34" charset="-120"/>
               </a:rPr>
-              <a:t>CTO &amp; Co-Founder</a:t>
+              <a:t>Senior Solidity Engineer</a:t>
             </a:r>
             <a:endParaRPr lang="en-US" sz="1100" dirty="0"/>
           </a:p>
@@ -6715,7 +6684,7 @@
                 <a:ea typeface="Calibri" pitchFamily="34" charset="-122"/>
                 <a:cs typeface="Calibri" pitchFamily="34" charset="-120"/>
               </a:rPr>
-              <a:t>Ex-Chainlink</a:t>
+              <a:t>Router, staking,</a:t>
             </a:r>
             <a:endParaRPr lang="en-US" sz="1100" dirty="0"/>
           </a:p>
@@ -6732,7 +6701,7 @@
                 <a:ea typeface="Calibri" pitchFamily="34" charset="-122"/>
                 <a:cs typeface="Calibri" pitchFamily="34" charset="-120"/>
               </a:rPr>
-              <a:t>Solidity Lead</a:t>
+              <a:t>bridge integration</a:t>
             </a:r>
             <a:endParaRPr lang="en-US" sz="1100" dirty="0"/>
           </a:p>
@@ -6836,7 +6805,7 @@
                 <a:ea typeface="Georgia" pitchFamily="34" charset="-122"/>
                 <a:cs typeface="Georgia" pitchFamily="34" charset="-120"/>
               </a:rPr>
-              <a:t>M</a:t>
+              <a:t>R</a:t>
             </a:r>
             <a:endParaRPr lang="en-US" sz="2200" dirty="0"/>
           </a:p>
@@ -6875,7 +6844,7 @@
                 <a:ea typeface="Georgia" pitchFamily="34" charset="-122"/>
                 <a:cs typeface="Georgia" pitchFamily="34" charset="-120"/>
               </a:rPr>
-              <a:t>Marcus Reid</a:t>
+              <a:t>Open role</a:t>
             </a:r>
             <a:endParaRPr lang="en-US" sz="1300" dirty="0"/>
           </a:p>
@@ -6914,7 +6883,7 @@
                 <a:ea typeface="Calibri" pitchFamily="34" charset="-122"/>
                 <a:cs typeface="Calibri" pitchFamily="34" charset="-120"/>
               </a:rPr>
-              <a:t>Head of Research</a:t>
+              <a:t>Solver / MEV Research</a:t>
             </a:r>
             <a:endParaRPr lang="en-US" sz="1100" dirty="0"/>
           </a:p>
@@ -6953,7 +6922,7 @@
                 <a:ea typeface="Calibri" pitchFamily="34" charset="-122"/>
                 <a:cs typeface="Calibri" pitchFamily="34" charset="-120"/>
               </a:rPr>
-              <a:t>Ex-Jump Crypto</a:t>
+              <a:t>Auction design</a:t>
             </a:r>
             <a:endParaRPr lang="en-US" sz="1100" dirty="0"/>
           </a:p>
@@ -6970,7 +6939,7 @@
                 <a:ea typeface="Calibri" pitchFamily="34" charset="-122"/>
                 <a:cs typeface="Calibri" pitchFamily="34" charset="-120"/>
               </a:rPr>
-              <a:t>MEV &amp; Auctions</a:t>
+              <a:t>&amp; solver economics</a:t>
             </a:r>
             <a:endParaRPr lang="en-US" sz="1100" dirty="0"/>
           </a:p>
@@ -7074,7 +7043,7 @@
                 <a:ea typeface="Georgia" pitchFamily="34" charset="-122"/>
                 <a:cs typeface="Georgia" pitchFamily="34" charset="-120"/>
               </a:rPr>
-              <a:t>J</a:t>
+              <a:t>G</a:t>
             </a:r>
             <a:endParaRPr lang="en-US" sz="2200" dirty="0"/>
           </a:p>
@@ -7113,7 +7082,7 @@
                 <a:ea typeface="Georgia" pitchFamily="34" charset="-122"/>
                 <a:cs typeface="Georgia" pitchFamily="34" charset="-120"/>
               </a:rPr>
-              <a:t>Julia Park</a:t>
+              <a:t>Open role</a:t>
             </a:r>
             <a:endParaRPr lang="en-US" sz="1300" dirty="0"/>
           </a:p>
@@ -7152,7 +7121,7 @@
                 <a:ea typeface="Calibri" pitchFamily="34" charset="-122"/>
                 <a:cs typeface="Calibri" pitchFamily="34" charset="-120"/>
               </a:rPr>
-              <a:t>Head of Growth</a:t>
+              <a:t>Growth &amp; Community</a:t>
             </a:r>
             <a:endParaRPr lang="en-US" sz="1100" dirty="0"/>
           </a:p>
@@ -7191,7 +7160,7 @@
                 <a:ea typeface="Calibri" pitchFamily="34" charset="-122"/>
                 <a:cs typeface="Calibri" pitchFamily="34" charset="-120"/>
               </a:rPr>
-              <a:t>Ex-Binance Labs</a:t>
+              <a:t>Discord, X,</a:t>
             </a:r>
             <a:endParaRPr lang="en-US" sz="1100" dirty="0"/>
           </a:p>
@@ -7208,7 +7177,7 @@
                 <a:ea typeface="Calibri" pitchFamily="34" charset="-122"/>
                 <a:cs typeface="Calibri" pitchFamily="34" charset="-120"/>
               </a:rPr>
-              <a:t>GTM DeFi</a:t>
+              <a:t>ecosystem partners</a:t>
             </a:r>
             <a:endParaRPr lang="en-US" sz="1100" dirty="0"/>
           </a:p>
@@ -7279,7 +7248,7 @@
                 <a:ea typeface="Georgia" pitchFamily="34" charset="-122"/>
                 <a:cs typeface="Georgia" pitchFamily="34" charset="-120"/>
               </a:rPr>
-              <a:t>Rodada Seed — $3M</a:t>
+              <a:t>Seed Round — $3M (equity)</a:t>
             </a:r>
             <a:endParaRPr lang="en-US" sz="3200" dirty="0"/>
           </a:p>
@@ -7354,7 +7323,7 @@
                 <a:ea typeface="Georgia" pitchFamily="34" charset="-122"/>
                 <a:cs typeface="Georgia" pitchFamily="34" charset="-120"/>
               </a:rPr>
-              <a:t>Uso dos Recursos</a:t>
+              <a:t>Use of Funds</a:t>
             </a:r>
             <a:endParaRPr lang="en-US" sz="1600" dirty="0"/>
           </a:p>
@@ -7461,7 +7430,7 @@
                 <a:ea typeface="Calibri" pitchFamily="34" charset="-122"/>
                 <a:cs typeface="Calibri" pitchFamily="34" charset="-120"/>
               </a:rPr>
-              <a:t>Desenvolvimento técnico</a:t>
+              <a:t>Technical development</a:t>
             </a:r>
             <a:endParaRPr lang="en-US" sz="1300" dirty="0"/>
           </a:p>
@@ -7568,7 +7537,7 @@
                 <a:ea typeface="Calibri" pitchFamily="34" charset="-122"/>
                 <a:cs typeface="Calibri" pitchFamily="34" charset="-120"/>
               </a:rPr>
-              <a:t>Auditorias de segurança</a:t>
+              <a:t>Security audits</a:t>
             </a:r>
             <a:endParaRPr lang="en-US" sz="1300" dirty="0"/>
           </a:p>
@@ -7675,7 +7644,7 @@
                 <a:ea typeface="Calibri" pitchFamily="34" charset="-122"/>
                 <a:cs typeface="Calibri" pitchFamily="34" charset="-120"/>
               </a:rPr>
-              <a:t>Liquidez inicial DEX</a:t>
+              <a:t>Liquidity &amp; community</a:t>
             </a:r>
             <a:endParaRPr lang="en-US" sz="1300" dirty="0"/>
           </a:p>
@@ -7782,7 +7751,7 @@
                 <a:ea typeface="Calibri" pitchFamily="34" charset="-122"/>
                 <a:cs typeface="Calibri" pitchFamily="34" charset="-120"/>
               </a:rPr>
-              <a:t>Legal e compliance</a:t>
+              <a:t>Legal &amp; compliance</a:t>
             </a:r>
             <a:endParaRPr lang="en-US" sz="1300" dirty="0"/>
           </a:p>
@@ -7889,7 +7858,7 @@
                 <a:ea typeface="Calibri" pitchFamily="34" charset="-122"/>
                 <a:cs typeface="Calibri" pitchFamily="34" charset="-120"/>
               </a:rPr>
-              <a:t>Operações</a:t>
+              <a:t>Operations</a:t>
             </a:r>
             <a:endParaRPr lang="en-US" sz="1300" dirty="0"/>
           </a:p>
@@ -7964,7 +7933,7 @@
                 <a:ea typeface="Georgia" pitchFamily="34" charset="-122"/>
                 <a:cs typeface="Georgia" pitchFamily="34" charset="-120"/>
               </a:rPr>
-              <a:t>Termos da Rodada</a:t>
+              <a:t>Round Terms</a:t>
             </a:r>
             <a:endParaRPr lang="en-US" sz="1600" dirty="0"/>
           </a:p>
@@ -8042,7 +8011,7 @@
                 <a:ea typeface="Calibri" pitchFamily="34" charset="-122"/>
                 <a:cs typeface="Calibri" pitchFamily="34" charset="-120"/>
               </a:rPr>
-              <a:t>A definir com investidores</a:t>
+              <a:t>To be agreed with investors</a:t>
             </a:r>
             <a:endParaRPr lang="en-US" sz="1200" dirty="0"/>
           </a:p>
@@ -8081,7 +8050,7 @@
                 <a:ea typeface="Calibri" pitchFamily="34" charset="-122"/>
                 <a:cs typeface="Calibri" pitchFamily="34" charset="-120"/>
               </a:rPr>
-              <a:t>Instrumento:</a:t>
+              <a:t>Instrument:</a:t>
             </a:r>
             <a:endParaRPr lang="en-US" sz="1200" dirty="0"/>
           </a:p>
@@ -8120,7 +8089,7 @@
                 <a:ea typeface="Calibri" pitchFamily="34" charset="-122"/>
                 <a:cs typeface="Calibri" pitchFamily="34" charset="-120"/>
               </a:rPr>
-              <a:t>SAFE / Token Warrant</a:t>
+              <a:t>Equity SAFE (no token allocation)</a:t>
             </a:r>
             <a:endParaRPr lang="en-US" sz="1200" dirty="0"/>
           </a:p>
@@ -8159,7 +8128,7 @@
                 <a:ea typeface="Calibri" pitchFamily="34" charset="-122"/>
                 <a:cs typeface="Calibri" pitchFamily="34" charset="-120"/>
               </a:rPr>
-              <a:t>Cliff/Vesting:</a:t>
+              <a:t>Tokens:</a:t>
             </a:r>
             <a:endParaRPr lang="en-US" sz="1200" dirty="0"/>
           </a:p>
@@ -8198,7 +8167,7 @@
                 <a:ea typeface="Calibri" pitchFamily="34" charset="-122"/>
                 <a:cs typeface="Calibri" pitchFamily="34" charset="-120"/>
               </a:rPr>
-              <a:t>6m cliff | 18m vesting</a:t>
+              <a:t>None — TRV was fair-launched</a:t>
             </a:r>
             <a:endParaRPr lang="en-US" sz="1200" dirty="0"/>
           </a:p>
@@ -8276,7 +8245,7 @@
                 <a:ea typeface="Calibri" pitchFamily="34" charset="-122"/>
                 <a:cs typeface="Calibri" pitchFamily="34" charset="-120"/>
               </a:rPr>
-              <a:t>Aberto</a:t>
+              <a:t>Open</a:t>
             </a:r>
             <a:endParaRPr lang="en-US" sz="1200" dirty="0"/>
           </a:p>
@@ -8315,7 +8284,7 @@
                 <a:ea typeface="Calibri" pitchFamily="34" charset="-122"/>
                 <a:cs typeface="Calibri" pitchFamily="34" charset="-120"/>
               </a:rPr>
-              <a:t>Fechamento:</a:t>
+              <a:t>Close:</a:t>
             </a:r>
             <a:endParaRPr lang="en-US" sz="1200" dirty="0"/>
           </a:p>
@@ -8354,7 +8323,7 @@
                 <a:ea typeface="Calibri" pitchFamily="34" charset="-122"/>
                 <a:cs typeface="Calibri" pitchFamily="34" charset="-120"/>
               </a:rPr>
-              <a:t>Alvo Q3 2026</a:t>
+              <a:t>Target Q1 2027</a:t>
             </a:r>
             <a:endParaRPr lang="en-US" sz="1200" dirty="0"/>
           </a:p>
@@ -8487,7 +8456,7 @@
                 <a:ea typeface="Georgia" pitchFamily="34" charset="-122"/>
                 <a:cs typeface="Georgia" pitchFamily="34" charset="-120"/>
               </a:rPr>
-              <a:t>Toda troca. Toda chain. Um protocolo.</a:t>
+              <a:t>Every swap. Every chain. One protocol.</a:t>
             </a:r>
             <a:endParaRPr lang="en-US" sz="3400" dirty="0"/>
           </a:p>
@@ -8565,7 +8534,7 @@
                 <a:ea typeface="Calibri" pitchFamily="34" charset="-122"/>
                 <a:cs typeface="Calibri" pitchFamily="34" charset="-120"/>
               </a:rPr>
-              <a:t>traverseprotocol.io  |  hello@traverseprotocol.io</a:t>
+              <a:t>traverse-protocol.netlify.app  |  x.com/TRVProtocol  |  discord.gg/xA6KsAnhM</a:t>
             </a:r>
             <a:endParaRPr lang="en-US" sz="1400" dirty="0"/>
           </a:p>
@@ -8636,7 +8605,7 @@
                 <a:ea typeface="Georgia" pitchFamily="34" charset="-122"/>
                 <a:cs typeface="Georgia" pitchFamily="34" charset="-120"/>
               </a:rPr>
-              <a:t>Aviso Legal</a:t>
+              <a:t>Disclaimer</a:t>
             </a:r>
             <a:endParaRPr lang="en-US" sz="2000" dirty="0"/>
           </a:p>
@@ -8675,7 +8644,7 @@
                 <a:ea typeface="Calibri" pitchFamily="34" charset="-122"/>
                 <a:cs typeface="Calibri" pitchFamily="34" charset="-120"/>
               </a:rPr>
-              <a:t>Este material é para fins informativos exclusivamente e não constitui oferta de valores mobiliários, conselho de investimento, financeiro ou jurídico. Tokens TRV representam direitos de utilidade e governança dentro do protocolo Traverse. Investimentos em ativos digitais envolvem riscos substanciais incluindo perda total do capital investido. Projeções e estimativas são ilustrativas e não garantem qualquer retorno. Consulte assessores jurídicos e financeiros qualificados antes de tomar qualquer decisão de investimento. Este documento não foi registrado em nenhuma autoridade regulatória.</a:t>
+              <a:t>This material is for information only and is not an offer of securities or investment, financial or legal advice. TRV launched on Solana via pump.fun and has no live protocol utility yet; planned utilities depend on a bridge, an independent audit and governance. Smart contracts are unaudited. Digital assets carry substantial risk, including total loss. Projections are illustrative and guarantee no return. Consult qualified legal and financial advisors before making any decision. This document has not been registered with any regulatory authority.</a:t>
             </a:r>
             <a:endParaRPr lang="en-US" sz="1100" dirty="0"/>
           </a:p>
@@ -8746,7 +8715,7 @@
                 <a:ea typeface="Georgia" pitchFamily="34" charset="-122"/>
                 <a:cs typeface="Georgia" pitchFamily="34" charset="-120"/>
               </a:rPr>
-              <a:t>Liquidez em DeFi está fragmentada</a:t>
+              <a:t>DeFi liquidity is fragmented</a:t>
             </a:r>
             <a:endParaRPr lang="en-US" sz="3400" dirty="0"/>
           </a:p>
@@ -8889,7 +8858,7 @@
                 <a:ea typeface="Calibri" pitchFamily="34" charset="-122"/>
                 <a:cs typeface="Calibri" pitchFamily="34" charset="-120"/>
               </a:rPr>
-              <a:t>Centenas de DEXs</a:t>
+              <a:t>Hundreds of DEXs</a:t>
             </a:r>
             <a:endParaRPr lang="en-US" sz="1400" dirty="0"/>
           </a:p>
@@ -8906,7 +8875,7 @@
                 <a:ea typeface="Calibri" pitchFamily="34" charset="-122"/>
                 <a:cs typeface="Calibri" pitchFamily="34" charset="-120"/>
               </a:rPr>
-              <a:t>sem comunicação</a:t>
+              <a:t>that don't talk to each other</a:t>
             </a:r>
             <a:endParaRPr lang="en-US" sz="1400" dirty="0"/>
           </a:p>
@@ -9049,7 +9018,7 @@
                 <a:ea typeface="Calibri" pitchFamily="34" charset="-122"/>
                 <a:cs typeface="Calibri" pitchFamily="34" charset="-120"/>
               </a:rPr>
-              <a:t>Disperso e inacessível</a:t>
+              <a:t>Scattered and unreachable</a:t>
             </a:r>
             <a:endParaRPr lang="en-US" sz="1400" dirty="0"/>
           </a:p>
@@ -9066,7 +9035,7 @@
                 <a:ea typeface="Calibri" pitchFamily="34" charset="-122"/>
                 <a:cs typeface="Calibri" pitchFamily="34" charset="-120"/>
               </a:rPr>
-              <a:t>de um único ponto</a:t>
+              <a:t>from a single entry point</a:t>
             </a:r>
             <a:endParaRPr lang="en-US" sz="1400" dirty="0"/>
           </a:p>
@@ -9209,7 +9178,7 @@
                 <a:ea typeface="Calibri" pitchFamily="34" charset="-122"/>
                 <a:cs typeface="Calibri" pitchFamily="34" charset="-120"/>
               </a:rPr>
-              <a:t>Usuário paga caro</a:t>
+              <a:t>Users pay a high price</a:t>
             </a:r>
             <a:endParaRPr lang="en-US" sz="1400" dirty="0"/>
           </a:p>
@@ -9226,7 +9195,7 @@
                 <a:ea typeface="Calibri" pitchFamily="34" charset="-122"/>
                 <a:cs typeface="Calibri" pitchFamily="34" charset="-120"/>
               </a:rPr>
-              <a:t>pela fragmentação</a:t>
+              <a:t>for fragmentation</a:t>
             </a:r>
             <a:endParaRPr lang="en-US" sz="1400" dirty="0"/>
           </a:p>
@@ -9265,7 +9234,7 @@
                 <a:ea typeface="Calibri" pitchFamily="34" charset="-122"/>
                 <a:cs typeface="Calibri" pitchFamily="34" charset="-120"/>
               </a:rPr>
-              <a:t>O usuário precisa de pontes manuais, múltiplas carteiras e sofre execução ruim.</a:t>
+              <a:t>Users juggle manual bridges and multiple wallets, and still get poor execution.</a:t>
             </a:r>
             <a:endParaRPr lang="en-US" sz="1300" dirty="0"/>
           </a:p>
@@ -9336,7 +9305,7 @@
                 <a:ea typeface="Georgia" pitchFamily="34" charset="-122"/>
                 <a:cs typeface="Georgia" pitchFamily="34" charset="-120"/>
               </a:rPr>
-              <a:t>Um mercado de $2.4 Trilhões</a:t>
+              <a:t>A large and growing market</a:t>
             </a:r>
             <a:endParaRPr lang="en-US" sz="3400" dirty="0"/>
           </a:p>
@@ -9411,7 +9380,7 @@
                 <a:ea typeface="Georgia" pitchFamily="34" charset="-122"/>
                 <a:cs typeface="Georgia" pitchFamily="34" charset="-120"/>
               </a:rPr>
-              <a:t>$150B+</a:t>
+              <a:t>$100B+</a:t>
             </a:r>
             <a:endParaRPr lang="en-US" sz="4000" dirty="0"/>
           </a:p>
@@ -9450,7 +9419,7 @@
                 <a:ea typeface="Calibri" pitchFamily="34" charset="-122"/>
                 <a:cs typeface="Calibri" pitchFamily="34" charset="-120"/>
               </a:rPr>
-              <a:t>TVL em DeFi</a:t>
+              <a:t>DeFi TVL</a:t>
             </a:r>
             <a:endParaRPr lang="en-US" sz="1300" dirty="0"/>
           </a:p>
@@ -9525,7 +9494,7 @@
                 <a:ea typeface="Georgia" pitchFamily="34" charset="-122"/>
                 <a:cs typeface="Georgia" pitchFamily="34" charset="-120"/>
               </a:rPr>
-              <a:t>$2.4T</a:t>
+              <a:t>$1T+</a:t>
             </a:r>
             <a:endParaRPr lang="en-US" sz="4000" dirty="0"/>
           </a:p>
@@ -9564,7 +9533,7 @@
                 <a:ea typeface="Calibri" pitchFamily="34" charset="-122"/>
                 <a:cs typeface="Calibri" pitchFamily="34" charset="-120"/>
               </a:rPr>
-              <a:t>Volume DEX Anual</a:t>
+              <a:t>Annual DEX volume</a:t>
             </a:r>
             <a:endParaRPr lang="en-US" sz="1300" dirty="0"/>
           </a:p>
@@ -9639,7 +9608,7 @@
                 <a:ea typeface="Georgia" pitchFamily="34" charset="-122"/>
                 <a:cs typeface="Georgia" pitchFamily="34" charset="-120"/>
               </a:rPr>
-              <a:t>400%</a:t>
+              <a:t>60+</a:t>
             </a:r>
             <a:endParaRPr lang="en-US" sz="4000" dirty="0"/>
           </a:p>
@@ -9678,7 +9647,7 @@
                 <a:ea typeface="Calibri" pitchFamily="34" charset="-122"/>
                 <a:cs typeface="Calibri" pitchFamily="34" charset="-120"/>
               </a:rPr>
-              <a:t>Crescimento Cross-Chain 2022–2025</a:t>
+              <a:t>Chains with their own liquidity</a:t>
             </a:r>
             <a:endParaRPr lang="en-US" sz="1300" dirty="0"/>
           </a:p>
@@ -9717,7 +9686,7 @@
                 <a:ea typeface="Calibri" pitchFamily="34" charset="-122"/>
                 <a:cs typeface="Calibri" pitchFamily="34" charset="-120"/>
               </a:rPr>
-              <a:t>O volume cross-chain cresce 4x mais rápido que o DeFi single-chain.</a:t>
+              <a:t>Approximate industry figures; sources vary. Every new chain adds another island of liquidity.</a:t>
             </a:r>
             <a:endParaRPr lang="en-US" sz="1400" dirty="0"/>
           </a:p>
@@ -9788,7 +9757,7 @@
                 <a:ea typeface="Georgia" pitchFamily="34" charset="-122"/>
                 <a:cs typeface="Georgia" pitchFamily="34" charset="-120"/>
               </a:rPr>
-              <a:t>Traverse: Um Fluxo. Qualquer Chain.</a:t>
+              <a:t>Traverse: One Flow. Any Chain.</a:t>
             </a:r>
             <a:endParaRPr lang="en-US" sz="3000" dirty="0"/>
           </a:p>
@@ -9924,7 +9893,7 @@
                 <a:ea typeface="Calibri" pitchFamily="34" charset="-122"/>
                 <a:cs typeface="Calibri" pitchFamily="34" charset="-120"/>
               </a:rPr>
-              <a:t>Usuário declara o que quer, não como fazer</a:t>
+              <a:t>Users state what they want, not how to get it</a:t>
             </a:r>
             <a:endParaRPr lang="en-US" sz="1300" dirty="0"/>
           </a:p>
@@ -10060,7 +10029,7 @@
                 <a:ea typeface="Calibri" pitchFamily="34" charset="-122"/>
                 <a:cs typeface="Calibri" pitchFamily="34" charset="-120"/>
               </a:rPr>
-              <a:t>Competição garante melhor execução</a:t>
+              <a:t>Competition drives better execution</a:t>
             </a:r>
             <a:endParaRPr lang="en-US" sz="1300" dirty="0"/>
           </a:p>
@@ -10196,7 +10165,7 @@
                 <a:ea typeface="Calibri" pitchFamily="34" charset="-122"/>
                 <a:cs typeface="Calibri" pitchFamily="34" charset="-120"/>
               </a:rPr>
-              <a:t>Qualquer token, qualquer rede, um fluxo</a:t>
+              <a:t>Any token, any network, one flow</a:t>
             </a:r>
             <a:endParaRPr lang="en-US" sz="1300" dirty="0"/>
           </a:p>
@@ -10293,7 +10262,7 @@
                 <a:ea typeface="Georgia" pitchFamily="34" charset="-122"/>
                 <a:cs typeface="Georgia" pitchFamily="34" charset="-120"/>
               </a:rPr>
-              <a:t>Sem Custódia</a:t>
+              <a:t>Non-Custodial</a:t>
             </a:r>
             <a:endParaRPr lang="en-US" sz="1600" dirty="0"/>
           </a:p>
@@ -10332,7 +10301,7 @@
                 <a:ea typeface="Calibri" pitchFamily="34" charset="-122"/>
                 <a:cs typeface="Calibri" pitchFamily="34" charset="-120"/>
               </a:rPr>
-              <a:t>Smart contracts verificáveis, sem intermediários</a:t>
+              <a:t>Verifiable smart contracts, no intermediaries</a:t>
             </a:r>
             <a:endParaRPr lang="en-US" sz="1300" dirty="0"/>
           </a:p>
@@ -10403,7 +10372,7 @@
                 <a:ea typeface="Georgia" pitchFamily="34" charset="-122"/>
                 <a:cs typeface="Georgia" pitchFamily="34" charset="-120"/>
               </a:rPr>
-              <a:t>Fluxo de Execução em 4 Passos</a:t>
+              <a:t>Execution in 4 Steps</a:t>
             </a:r>
             <a:endParaRPr lang="en-US" sz="3200" dirty="0"/>
           </a:p>
@@ -10478,7 +10447,7 @@
                 <a:ea typeface="Calibri" pitchFamily="34" charset="-122"/>
                 <a:cs typeface="Calibri" pitchFamily="34" charset="-120"/>
               </a:rPr>
-              <a:t>USUÁRIO</a:t>
+              <a:t>USER</a:t>
             </a:r>
             <a:endParaRPr lang="en-US" sz="1300" dirty="0"/>
           </a:p>
@@ -10517,7 +10486,7 @@
                 <a:ea typeface="Calibri" pitchFamily="34" charset="-122"/>
                 <a:cs typeface="Calibri" pitchFamily="34" charset="-120"/>
               </a:rPr>
-              <a:t>Submete intent</a:t>
+              <a:t>Submits a signed</a:t>
             </a:r>
             <a:endParaRPr lang="en-US" sz="1200" dirty="0"/>
           </a:p>
@@ -10534,7 +10503,7 @@
                 <a:ea typeface="Calibri" pitchFamily="34" charset="-122"/>
                 <a:cs typeface="Calibri" pitchFamily="34" charset="-120"/>
               </a:rPr>
-              <a:t>assinado (EIP-712):</a:t>
+              <a:t>intent (EIP-712):</a:t>
             </a:r>
             <a:endParaRPr lang="en-US" sz="1200" dirty="0"/>
           </a:p>
@@ -10551,7 +10520,7 @@
                 <a:ea typeface="Calibri" pitchFamily="34" charset="-122"/>
                 <a:cs typeface="Calibri" pitchFamily="34" charset="-120"/>
               </a:rPr>
-              <a:t>quer X token</a:t>
+              <a:t>wants token X</a:t>
             </a:r>
             <a:endParaRPr lang="en-US" sz="1200" dirty="0"/>
           </a:p>
@@ -10568,7 +10537,7 @@
                 <a:ea typeface="Calibri" pitchFamily="34" charset="-122"/>
                 <a:cs typeface="Calibri" pitchFamily="34" charset="-120"/>
               </a:rPr>
-              <a:t>na chain Y</a:t>
+              <a:t>on chain Y</a:t>
             </a:r>
             <a:endParaRPr lang="en-US" sz="1200" dirty="0"/>
           </a:p>
@@ -10672,7 +10641,7 @@
                 <a:ea typeface="Calibri" pitchFamily="34" charset="-122"/>
                 <a:cs typeface="Calibri" pitchFamily="34" charset="-120"/>
               </a:rPr>
-              <a:t>LEILÃO</a:t>
+              <a:t>AUCTION</a:t>
             </a:r>
             <a:endParaRPr lang="en-US" sz="1300" dirty="0"/>
           </a:p>
@@ -10711,7 +10680,7 @@
                 <a:ea typeface="Calibri" pitchFamily="34" charset="-122"/>
                 <a:cs typeface="Calibri" pitchFamily="34" charset="-120"/>
               </a:rPr>
-              <a:t>Solvers competem</a:t>
+              <a:t>Solvers compete</a:t>
             </a:r>
             <a:endParaRPr lang="en-US" sz="1200" dirty="0"/>
           </a:p>
@@ -10728,7 +10697,7 @@
                 <a:ea typeface="Calibri" pitchFamily="34" charset="-122"/>
                 <a:cs typeface="Calibri" pitchFamily="34" charset="-120"/>
               </a:rPr>
-              <a:t>oferecendo melhor</a:t>
+              <a:t>by offering the best</a:t>
             </a:r>
             <a:endParaRPr lang="en-US" sz="1200" dirty="0"/>
           </a:p>
@@ -10888,7 +10857,7 @@
                 <a:ea typeface="Calibri" pitchFamily="34" charset="-122"/>
                 <a:cs typeface="Calibri" pitchFamily="34" charset="-120"/>
               </a:rPr>
-              <a:t>Vencedor executa</a:t>
+              <a:t>Winner executes</a:t>
             </a:r>
             <a:endParaRPr lang="en-US" sz="1200" dirty="0"/>
           </a:p>
@@ -10922,7 +10891,7 @@
                 <a:ea typeface="Calibri" pitchFamily="34" charset="-122"/>
                 <a:cs typeface="Calibri" pitchFamily="34" charset="-120"/>
               </a:rPr>
-              <a:t>atomicamente</a:t>
+              <a:t>atomically</a:t>
             </a:r>
             <a:endParaRPr lang="en-US" sz="1200" dirty="0"/>
           </a:p>
@@ -11026,7 +10995,7 @@
                 <a:ea typeface="Calibri" pitchFamily="34" charset="-122"/>
                 <a:cs typeface="Calibri" pitchFamily="34" charset="-120"/>
               </a:rPr>
-              <a:t>USUÁRIO</a:t>
+              <a:t>USER</a:t>
             </a:r>
             <a:endParaRPr lang="en-US" sz="1300" dirty="0"/>
           </a:p>
@@ -11065,7 +11034,7 @@
                 <a:ea typeface="Calibri" pitchFamily="34" charset="-122"/>
                 <a:cs typeface="Calibri" pitchFamily="34" charset="-120"/>
               </a:rPr>
-              <a:t>Recebe tokens na</a:t>
+              <a:t>Receives tokens on</a:t>
             </a:r>
             <a:endParaRPr lang="en-US" sz="1200" dirty="0"/>
           </a:p>
@@ -11082,7 +11051,7 @@
                 <a:ea typeface="Calibri" pitchFamily="34" charset="-122"/>
                 <a:cs typeface="Calibri" pitchFamily="34" charset="-120"/>
               </a:rPr>
-              <a:t>chain de destino</a:t>
+              <a:t>the destination chain</a:t>
             </a:r>
             <a:endParaRPr lang="en-US" sz="1200" dirty="0"/>
           </a:p>
@@ -11121,7 +11090,7 @@
                 <a:ea typeface="Calibri" pitchFamily="34" charset="-122"/>
                 <a:cs typeface="Calibri" pitchFamily="34" charset="-120"/>
               </a:rPr>
-              <a:t>Solvers precisam de stake em TRV. Má execução = slashing.</a:t>
+              <a:t>Solvers stake TRV (planned). Bad execution = slashing.</a:t>
             </a:r>
             <a:endParaRPr lang="en-US" sz="1300" dirty="0"/>
           </a:p>
@@ -11192,7 +11161,7 @@
                 <a:ea typeface="Georgia" pitchFamily="34" charset="-122"/>
                 <a:cs typeface="Georgia" pitchFamily="34" charset="-120"/>
               </a:rPr>
-              <a:t>Arquitetura Técnica</a:t>
+              <a:t>Technical Architecture</a:t>
             </a:r>
             <a:endParaRPr lang="en-US" sz="3200" dirty="0"/>
           </a:p>
@@ -11235,7 +11204,7 @@
                 <a:ea typeface="Calibri" pitchFamily="34" charset="-122"/>
                 <a:cs typeface="Calibri" pitchFamily="34" charset="-120"/>
               </a:rPr>
-              <a:t>EIP-712: Intents assinados e verificáveis</a:t>
+              <a:t>EIP-712: signed, verifiable intents</a:t>
             </a:r>
             <a:endParaRPr lang="en-US" sz="1300" dirty="0"/>
           </a:p>
@@ -11256,7 +11225,7 @@
                 <a:ea typeface="Calibri" pitchFamily="34" charset="-122"/>
                 <a:cs typeface="Calibri" pitchFamily="34" charset="-120"/>
               </a:rPr>
-              <a:t>Dutch Auction: Leilão de execução decrescente</a:t>
+              <a:t>Dutch Auction: descending execution auction</a:t>
             </a:r>
             <a:endParaRPr lang="en-US" sz="1300" dirty="0"/>
           </a:p>
@@ -11277,7 +11246,7 @@
                 <a:ea typeface="Calibri" pitchFamily="34" charset="-122"/>
                 <a:cs typeface="Calibri" pitchFamily="34" charset="-120"/>
               </a:rPr>
-              <a:t>Solver Registry: Registro com stake mínimo (10k TRV)</a:t>
+              <a:t>Solver Registry: minimum stake (10k TRV, planned)</a:t>
             </a:r>
             <a:endParaRPr lang="en-US" sz="1300" dirty="0"/>
           </a:p>
@@ -11298,7 +11267,7 @@
                 <a:ea typeface="Calibri" pitchFamily="34" charset="-122"/>
                 <a:cs typeface="Calibri" pitchFamily="34" charset="-120"/>
               </a:rPr>
-              <a:t>Settlement: Entrega atômica cross-chain</a:t>
+              <a:t>Settlement: atomic cross-chain delivery</a:t>
             </a:r>
             <a:endParaRPr lang="en-US" sz="1300" dirty="0"/>
           </a:p>
@@ -11316,7 +11285,7 @@
                 <a:ea typeface="Calibri" pitchFamily="34" charset="-122"/>
                 <a:cs typeface="Calibri" pitchFamily="34" charset="-120"/>
               </a:rPr>
-              <a:t>Governor + Timelock: Governança on-chain</a:t>
+              <a:t>Governor + Timelock: on-chain governance</a:t>
             </a:r>
             <a:endParaRPr lang="en-US" sz="1300" dirty="0"/>
           </a:p>
@@ -11729,7 +11698,7 @@
                 <a:ea typeface="Georgia" pitchFamily="34" charset="-122"/>
                 <a:cs typeface="Georgia" pitchFamily="34" charset="-120"/>
               </a:rPr>
-              <a:t>Por Que Agora? Por Que Traverse?</a:t>
+              <a:t>Why Now? Why Traverse?</a:t>
             </a:r>
             <a:endParaRPr lang="en-US" sz="3200" dirty="0"/>
           </a:p>
@@ -11783,7 +11752,7 @@
                           <a:ea typeface="Calibri" pitchFamily="34" charset="-122"/>
                           <a:cs typeface="Calibri" pitchFamily="34" charset="-120"/>
                         </a:rPr>
-                        <a:t>Recurso</a:t>
+                        <a:t>Feature</a:t>
                       </a:r>
                       <a:endParaRPr lang="en-US" sz="1200" dirty="0">
                         <a:latin typeface="Calibri" charset="0"/>
@@ -12193,7 +12162,7 @@
                           <a:ea typeface="Calibri" pitchFamily="34" charset="-122"/>
                           <a:cs typeface="Calibri" pitchFamily="34" charset="-120"/>
                         </a:rPr>
-                        <a:t>Cross-chain nativo</a:t>
+                        <a:t>Native cross-chain</a:t>
                       </a:r>
                       <a:endParaRPr lang="en-US" sz="1200" dirty="0">
                         <a:latin typeface="Calibri" charset="0"/>
@@ -12329,7 +12298,7 @@
                           <a:ea typeface="Calibri" pitchFamily="34" charset="-122"/>
                           <a:cs typeface="Calibri" pitchFamily="34" charset="-120"/>
                         </a:rPr>
-                        <a:t>Parcial</a:t>
+                        <a:t>Partial</a:t>
                       </a:r>
                       <a:endParaRPr lang="en-US" sz="1200" dirty="0">
                         <a:latin typeface="Calibri" charset="0"/>
@@ -13833,7 +13802,7 @@
                           <a:ea typeface="Calibri" pitchFamily="34" charset="-122"/>
                           <a:cs typeface="Calibri" pitchFamily="34" charset="-120"/>
                         </a:rPr>
-                        <a:t>Revenue sharing TRV</a:t>
+                        <a:t>TRV fee share (planned)</a:t>
                       </a:r>
                       <a:endParaRPr lang="en-US" sz="1200" dirty="0">
                         <a:latin typeface="Calibri" charset="0"/>
@@ -14173,7 +14142,7 @@
                           <a:ea typeface="Calibri" pitchFamily="34" charset="-122"/>
                           <a:cs typeface="Calibri" pitchFamily="34" charset="-120"/>
                         </a:rPr>
-                        <a:t>Parcial</a:t>
+                        <a:t>Partial</a:t>
                       </a:r>
                       <a:endParaRPr lang="en-US" sz="1200" dirty="0">
                         <a:latin typeface="Calibri" charset="0"/>
@@ -14294,7 +14263,7 @@
                 <a:ea typeface="Georgia" pitchFamily="34" charset="-122"/>
                 <a:cs typeface="Georgia" pitchFamily="34" charset="-120"/>
               </a:rPr>
-              <a:t>TRV — Utilidade Real, Não Decoração</a:t>
+              <a:t>TRV — Planned Utility (after bridge &amp; audit)</a:t>
             </a:r>
             <a:endParaRPr lang="en-US" sz="2800" dirty="0"/>
           </a:p>
@@ -14437,7 +14406,7 @@
                 <a:ea typeface="Calibri" pitchFamily="34" charset="-122"/>
                 <a:cs typeface="Calibri" pitchFamily="34" charset="-120"/>
               </a:rPr>
-              <a:t>10k TRV mínimo</a:t>
+              <a:t>10k TRV minimum</a:t>
             </a:r>
             <a:endParaRPr lang="en-US" sz="1200" dirty="0"/>
           </a:p>
@@ -14454,7 +14423,7 @@
                 <a:ea typeface="Calibri" pitchFamily="34" charset="-122"/>
                 <a:cs typeface="Calibri" pitchFamily="34" charset="-120"/>
               </a:rPr>
-              <a:t>por solver</a:t>
+              <a:t>per solver</a:t>
             </a:r>
             <a:endParaRPr lang="en-US" sz="1200" dirty="0"/>
           </a:p>
@@ -14471,7 +14440,7 @@
                 <a:ea typeface="Calibri" pitchFamily="34" charset="-122"/>
                 <a:cs typeface="Calibri" pitchFamily="34" charset="-120"/>
               </a:rPr>
-              <a:t>Colateral contra</a:t>
+              <a:t>Collateral against</a:t>
             </a:r>
             <a:endParaRPr lang="en-US" sz="1200" dirty="0"/>
           </a:p>
@@ -14488,7 +14457,7 @@
                 <a:ea typeface="Calibri" pitchFamily="34" charset="-122"/>
                 <a:cs typeface="Calibri" pitchFamily="34" charset="-120"/>
               </a:rPr>
-              <a:t>má execução</a:t>
+              <a:t>bad execution</a:t>
             </a:r>
             <a:endParaRPr lang="en-US" sz="1200" dirty="0"/>
           </a:p>
@@ -14592,7 +14561,7 @@
                 <a:ea typeface="Georgia" pitchFamily="34" charset="-122"/>
                 <a:cs typeface="Georgia" pitchFamily="34" charset="-120"/>
               </a:rPr>
-              <a:t>GOVERNANÇA</a:t>
+              <a:t>GOVERNANCE</a:t>
             </a:r>
             <a:endParaRPr lang="en-US" sz="1400" dirty="0"/>
           </a:p>
@@ -14631,7 +14600,7 @@
                 <a:ea typeface="Calibri" pitchFamily="34" charset="-122"/>
                 <a:cs typeface="Calibri" pitchFamily="34" charset="-120"/>
               </a:rPr>
-              <a:t>1 TRV = 1 voto</a:t>
+              <a:t>1 TRV = 1 vote</a:t>
             </a:r>
             <a:endParaRPr lang="en-US" sz="1200" dirty="0"/>
           </a:p>
@@ -14648,7 +14617,7 @@
                 <a:ea typeface="Calibri" pitchFamily="34" charset="-122"/>
                 <a:cs typeface="Calibri" pitchFamily="34" charset="-120"/>
               </a:rPr>
-              <a:t>Controla fee,</a:t>
+              <a:t>Controls fees,</a:t>
             </a:r>
             <a:endParaRPr lang="en-US" sz="1200" dirty="0"/>
           </a:p>
@@ -14665,7 +14634,7 @@
                 <a:ea typeface="Calibri" pitchFamily="34" charset="-122"/>
                 <a:cs typeface="Calibri" pitchFamily="34" charset="-120"/>
               </a:rPr>
-              <a:t>parâmetros,</a:t>
+              <a:t>parameters,</a:t>
             </a:r>
             <a:endParaRPr lang="en-US" sz="1200" dirty="0"/>
           </a:p>
@@ -14682,7 +14651,7 @@
                 <a:ea typeface="Calibri" pitchFamily="34" charset="-122"/>
                 <a:cs typeface="Calibri" pitchFamily="34" charset="-120"/>
               </a:rPr>
-              <a:t>tesouro</a:t>
+              <a:t>treasury</a:t>
             </a:r>
             <a:endParaRPr lang="en-US" sz="1200" dirty="0"/>
           </a:p>
@@ -14786,7 +14755,7 @@
                 <a:ea typeface="Georgia" pitchFamily="34" charset="-122"/>
                 <a:cs typeface="Georgia" pitchFamily="34" charset="-120"/>
               </a:rPr>
-              <a:t>DESCONTO</a:t>
+              <a:t>DISCOUNT</a:t>
             </a:r>
             <a:endParaRPr lang="en-US" sz="1400" dirty="0"/>
           </a:p>
@@ -14825,7 +14794,7 @@
                 <a:ea typeface="Calibri" pitchFamily="34" charset="-122"/>
                 <a:cs typeface="Calibri" pitchFamily="34" charset="-120"/>
               </a:rPr>
-              <a:t>Até 40% off</a:t>
+              <a:t>Up to 50% off</a:t>
             </a:r>
             <a:endParaRPr lang="en-US" sz="1200" dirty="0"/>
           </a:p>
@@ -14842,7 +14811,7 @@
                 <a:ea typeface="Calibri" pitchFamily="34" charset="-122"/>
                 <a:cs typeface="Calibri" pitchFamily="34" charset="-120"/>
               </a:rPr>
-              <a:t>nas fees</a:t>
+              <a:t>routing fees</a:t>
             </a:r>
             <a:endParaRPr lang="en-US" sz="1200" dirty="0"/>
           </a:p>
@@ -14859,7 +14828,7 @@
                 <a:ea typeface="Calibri" pitchFamily="34" charset="-122"/>
                 <a:cs typeface="Calibri" pitchFamily="34" charset="-120"/>
               </a:rPr>
-              <a:t>Tiers por</a:t>
+              <a:t>Tiers by</a:t>
             </a:r>
             <a:endParaRPr lang="en-US" sz="1200" dirty="0"/>
           </a:p>
@@ -14876,7 +14845,7 @@
                 <a:ea typeface="Calibri" pitchFamily="34" charset="-122"/>
                 <a:cs typeface="Calibri" pitchFamily="34" charset="-120"/>
               </a:rPr>
-              <a:t>quantidade holdada</a:t>
+              <a:t>amount held</a:t>
             </a:r>
             <a:endParaRPr lang="en-US" sz="1200" dirty="0"/>
           </a:p>
@@ -14980,7 +14949,7 @@
                 <a:ea typeface="Georgia" pitchFamily="34" charset="-122"/>
                 <a:cs typeface="Georgia" pitchFamily="34" charset="-120"/>
               </a:rPr>
-              <a:t>RECEITA</a:t>
+              <a:t>FEE SHARE</a:t>
             </a:r>
             <a:endParaRPr lang="en-US" sz="1400" dirty="0"/>
           </a:p>
@@ -15019,7 +14988,7 @@
                 <a:ea typeface="Calibri" pitchFamily="34" charset="-122"/>
                 <a:cs typeface="Calibri" pitchFamily="34" charset="-120"/>
               </a:rPr>
-              <a:t>70% das fees</a:t>
+              <a:t>70% of fees</a:t>
             </a:r>
             <a:endParaRPr lang="en-US" sz="1200" dirty="0"/>
           </a:p>
@@ -15036,7 +15005,7 @@
                 <a:ea typeface="Calibri" pitchFamily="34" charset="-122"/>
                 <a:cs typeface="Calibri" pitchFamily="34" charset="-120"/>
               </a:rPr>
-              <a:t>para stakers</a:t>
+              <a:t>to stakers (proposed)</a:t>
             </a:r>
             <a:endParaRPr lang="en-US" sz="1200" dirty="0"/>
           </a:p>
@@ -15053,7 +15022,7 @@
                 <a:ea typeface="Calibri" pitchFamily="34" charset="-122"/>
                 <a:cs typeface="Calibri" pitchFamily="34" charset="-120"/>
               </a:rPr>
-              <a:t>APY real proporcional</a:t>
+              <a:t>Subject to legal</a:t>
             </a:r>
             <a:endParaRPr lang="en-US" sz="1200" dirty="0"/>
           </a:p>
@@ -15070,7 +15039,7 @@
                 <a:ea typeface="Calibri" pitchFamily="34" charset="-122"/>
                 <a:cs typeface="Calibri" pitchFamily="34" charset="-120"/>
               </a:rPr>
-              <a:t>ao volume</a:t>
+              <a:t>review &amp; governance</a:t>
             </a:r>
             <a:endParaRPr lang="en-US" sz="1200" dirty="0"/>
           </a:p>
@@ -15141,7 +15110,7 @@
                 <a:ea typeface="Georgia" pitchFamily="34" charset="-122"/>
                 <a:cs typeface="Georgia" pitchFamily="34" charset="-120"/>
               </a:rPr>
-              <a:t>Distribuição do Supply — 1 Bilhão TRV</a:t>
+              <a:t>Supply — 1 Billion TRV, Fair Launch</a:t>
             </a:r>
             <a:endParaRPr lang="en-US" sz="3200" dirty="0"/>
           </a:p>
@@ -15232,7 +15201,7 @@
                 <a:ea typeface="Calibri" pitchFamily="34" charset="-122"/>
                 <a:cs typeface="Calibri" pitchFamily="34" charset="-120"/>
               </a:rPr>
-              <a:t>Supply fixo: 1B TRV, sem mint</a:t>
+              <a:t>Fixed supply: 1B TRV, mint authority revoked</a:t>
             </a:r>
             <a:endParaRPr lang="en-US" sz="1300" dirty="0"/>
           </a:p>
@@ -15307,7 +15276,7 @@
                 <a:ea typeface="Calibri" pitchFamily="34" charset="-122"/>
                 <a:cs typeface="Calibri" pitchFamily="34" charset="-120"/>
               </a:rPr>
-              <a:t>Equipe: cliff 12m + vesting 36m</a:t>
+              <a:t>Team: 0% pre-allocated. Creator bought ~0.62% on the open curve (disclosed)</a:t>
             </a:r>
             <a:endParaRPr lang="en-US" sz="1300" dirty="0"/>
           </a:p>
@@ -15382,7 +15351,7 @@
                 <a:ea typeface="Calibri" pitchFamily="34" charset="-122"/>
                 <a:cs typeface="Calibri" pitchFamily="34" charset="-120"/>
               </a:rPr>
-              <a:t>LP travado em contrato por 12 meses</a:t>
+              <a:t>CA: AqYxQFndwosnbXeQXXnqyJUw471YddxbZqkwosDvpump</a:t>
             </a:r>
             <a:endParaRPr lang="en-US" sz="1300" dirty="0"/>
           </a:p>

</xml_diff>